<commit_message>
feat(sesion-10): demos de fallos forzados y materiales densificados
Agrega escenarios JSON, demo_force_fail, contrato incompleto/invalido y alinea PPT/docs al lab sincronizado sin retos.

Co-authored-by: Cursor <cursoragent@cursor.com>
</commit_message>
<xml_diff>
--- a/sesiones/sesion-10/sesion-10.pptx
+++ b/sesiones/sesion-10/sesion-10.pptx
@@ -24,6 +24,9 @@
     <p:sldId id="272" r:id="rId23"/>
     <p:sldId id="273" r:id="rId24"/>
     <p:sldId id="274" r:id="rId25"/>
+    <p:sldId id="275" r:id="rId26"/>
+    <p:sldId id="276" r:id="rId27"/>
+    <p:sldId id="277" r:id="rId28"/>
   </p:sldIdLst>
   <p:sldSz cx="12191695" cy="6858000" type="screen4x3"/>
   <p:notesSz cx="6858000" cy="9144000"/>
@@ -3267,7 +3270,7 @@
                 </a:solidFill>
                 <a:latin typeface="Calibri"/>
               </a:rPr>
-              <a:t>• Hoy: integrar el juez · demo E2E de métricas · retos · cierre</a:t>
+              <a:t>• Hoy: integrar el juez · correr escenarios JSON · desbloquear un release · cierre</a:t>
             </a:r>
           </a:p>
           <a:p>
@@ -3413,7 +3416,7 @@
                 </a:solidFill>
                 <a:latin typeface="Calibri"/>
               </a:rPr>
-              <a:t>Core del juez (config, no magia)</a:t>
+              <a:t>Lab del juez</a:t>
             </a:r>
           </a:p>
         </p:txBody>
@@ -3447,7 +3450,7 @@
                 </a:solidFill>
                 <a:latin typeface="Calibri"/>
               </a:rPr>
-              <a:t>Sesión 10 · Release Gate · Cierre · Slide 9b</a:t>
+              <a:t>Sesión 10 · Release Gate · Cierre · Slide 8</a:t>
             </a:r>
           </a:p>
         </p:txBody>
@@ -3486,7 +3489,7 @@
                 </a:solidFill>
                 <a:latin typeface="Calibri"/>
               </a:rPr>
-              <a:t>• pyproject.toml — solo pytest; pythonpath = ["src"]</a:t>
+              <a:t>• Carpeta: proyecto-integrador/release-gate</a:t>
             </a:r>
           </a:p>
           <a:p>
@@ -3502,7 +3505,7 @@
                 </a:solidFill>
                 <a:latin typeface="Calibri"/>
               </a:rPr>
-              <a:t>• src/release_gate/__init__.py — THRESHOLDS + evaluate()</a:t>
+              <a:t>• Mismos comandos en tu máquina y en pantalla del instructor</a:t>
             </a:r>
           </a:p>
           <a:p>
@@ -3518,39 +3521,7 @@
                 </a:solidFill>
                 <a:latin typeface="Calibri"/>
               </a:rPr>
-              <a:t>• run_gate.py — atajo: mete src/ en el path (Windows-friendly)</a:t>
-            </a:r>
-          </a:p>
-          <a:p>
-            <a:pPr>
-              <a:spcAft>
-                <a:spcPts val="1000"/>
-              </a:spcAft>
-            </a:pPr>
-            <a:r>
-              <a:rPr sz="1800" b="0">
-                <a:solidFill>
-                  <a:srgbClr val="2C3E50"/>
-                </a:solidFill>
-                <a:latin typeface="Calibri"/>
-              </a:rPr>
-              <a:t>• metrics/*.json — entradas de demo (simulan artefactos de CI)</a:t>
-            </a:r>
-          </a:p>
-          <a:p>
-            <a:pPr>
-              <a:spcAft>
-                <a:spcPts val="1000"/>
-              </a:spcAft>
-            </a:pPr>
-            <a:r>
-              <a:rPr sz="1800" b="0">
-                <a:solidFill>
-                  <a:srgbClr val="2C3E50"/>
-                </a:solidFill>
-                <a:latin typeface="Calibri"/>
-              </a:rPr>
-              <a:t>• tests/ — el juez se prueba a sí mismo antes de juzgar</a:t>
+              <a:t>• Objetivo: ver exit 0 y exit 1 y leer el JSON</a:t>
             </a:r>
           </a:p>
         </p:txBody>
@@ -3680,7 +3651,7 @@
                 </a:solidFill>
                 <a:latin typeface="Calibri"/>
               </a:rPr>
-              <a:t>metrics/healthy.json → exit 0</a:t>
+              <a:t>Primero la suite del lab</a:t>
             </a:r>
           </a:p>
         </p:txBody>
@@ -3714,7 +3685,7 @@
                 </a:solidFill>
                 <a:latin typeface="Calibri"/>
               </a:rPr>
-              <a:t>Sesión 10 · Release Gate · Cierre · Slide 10</a:t>
+              <a:t>Sesión 10 · Release Gate · Cierre · Slide 9</a:t>
             </a:r>
           </a:p>
         </p:txBody>
@@ -3753,7 +3724,7 @@
                 </a:solidFill>
                 <a:latin typeface="Calibri"/>
               </a:rPr>
-              <a:t>• Comando: uv run python run_gate.py metrics/healthy.json</a:t>
+              <a:t>• uv sync --group dev</a:t>
             </a:r>
           </a:p>
           <a:p>
@@ -3769,7 +3740,7 @@
                 </a:solidFill>
                 <a:latin typeface="Calibri"/>
               </a:rPr>
-              <a:t>• Los 6 checks en true · failed: [] · passed: true</a:t>
+              <a:t>• uv run pytest -v → 16 passed</a:t>
             </a:r>
           </a:p>
           <a:p>
@@ -3785,7 +3756,7 @@
                 </a:solidFill>
                 <a:latin typeface="Calibri"/>
               </a:rPr>
-              <a:t>• Stderr: RELEASE: PASA</a:t>
+              <a:t>• Escenarios de metrics/ + contrato de demos/ (incompleto/inválido)</a:t>
             </a:r>
           </a:p>
           <a:p>
@@ -3801,7 +3772,23 @@
                 </a:solidFill>
                 <a:latin typeface="Calibri"/>
               </a:rPr>
-              <a:t>• Ese es el merge feliz</a:t>
+              <a:t>• El juez tiene tests propios (no es magia)</a:t>
+            </a:r>
+          </a:p>
+          <a:p>
+            <a:pPr>
+              <a:spcAft>
+                <a:spcPts val="1000"/>
+              </a:spcAft>
+            </a:pPr>
+            <a:r>
+              <a:rPr sz="1800" b="0">
+                <a:solidFill>
+                  <a:srgbClr val="2C3E50"/>
+                </a:solidFill>
+                <a:latin typeface="Calibri"/>
+              </a:rPr>
+              <a:t>• Task: task test:gate</a:t>
             </a:r>
           </a:p>
         </p:txBody>
@@ -3931,7 +3918,7 @@
                 </a:solidFill>
                 <a:latin typeface="Calibri"/>
               </a:rPr>
-              <a:t>mutation 0.80 &lt; 0.90</a:t>
+              <a:t>Core del juez (config, no magia)</a:t>
             </a:r>
           </a:p>
         </p:txBody>
@@ -3965,7 +3952,7 @@
                 </a:solidFill>
                 <a:latin typeface="Calibri"/>
               </a:rPr>
-              <a:t>Sesión 10 · Release Gate · Cierre · Slide 11</a:t>
+              <a:t>Sesión 10 · Release Gate · Cierre · Slide 9b</a:t>
             </a:r>
           </a:p>
         </p:txBody>
@@ -4004,7 +3991,7 @@
                 </a:solidFill>
                 <a:latin typeface="Calibri"/>
               </a:rPr>
-              <a:t>• Comando: uv run python run_gate.py metrics/blocked_mutation.json</a:t>
+              <a:t>• pyproject.toml — solo pytest; pythonpath = ["src"]</a:t>
             </a:r>
           </a:p>
           <a:p>
@@ -4020,7 +4007,7 @@
                 </a:solidFill>
                 <a:latin typeface="Calibri"/>
               </a:rPr>
-              <a:t>• Solo mutation: false · exit 1</a:t>
+              <a:t>• src/release_gate/__init__.py — THRESHOLDS + evaluate()</a:t>
             </a:r>
           </a:p>
           <a:p>
@@ -4036,7 +4023,7 @@
                 </a:solidFill>
                 <a:latin typeface="Calibri"/>
               </a:rPr>
-              <a:t>• Mismo patrón del reto práctico (retos/reto-practico)</a:t>
+              <a:t>• run_gate.py — atajo: mete src/ en el path (Windows-friendly)</a:t>
             </a:r>
           </a:p>
           <a:p>
@@ -4052,7 +4039,23 @@
                 </a:solidFill>
                 <a:latin typeface="Calibri"/>
               </a:rPr>
-              <a:t>• El resto puede estar verde: igual se bloquea</a:t>
+              <a:t>• metrics/*.json — escenarios de demo (simulan artefactos de CI)</a:t>
+            </a:r>
+          </a:p>
+          <a:p>
+            <a:pPr>
+              <a:spcAft>
+                <a:spcPts val="1000"/>
+              </a:spcAft>
+            </a:pPr>
+            <a:r>
+              <a:rPr sz="1800" b="0">
+                <a:solidFill>
+                  <a:srgbClr val="2C3E50"/>
+                </a:solidFill>
+                <a:latin typeface="Calibri"/>
+              </a:rPr>
+              <a:t>• scripts/run_all_demos.py — arco completo en un comando</a:t>
             </a:r>
           </a:p>
         </p:txBody>
@@ -4182,7 +4185,7 @@
                 </a:solidFill>
                 <a:latin typeface="Calibri"/>
               </a:rPr>
-              <a:t>Etapa 9 dentro del juez</a:t>
+              <a:t>metrics/healthy.json → exit 0</a:t>
             </a:r>
           </a:p>
         </p:txBody>
@@ -4216,7 +4219,7 @@
                 </a:solidFill>
                 <a:latin typeface="Calibri"/>
               </a:rPr>
-              <a:t>Sesión 10 · Release Gate · Cierre · Slide 12</a:t>
+              <a:t>Sesión 10 · Release Gate · Cierre · Slide 10</a:t>
             </a:r>
           </a:p>
         </p:txBody>
@@ -4255,7 +4258,7 @@
                 </a:solidFill>
                 <a:latin typeface="Calibri"/>
               </a:rPr>
-              <a:t>• Comando: uv run python run_gate.py metrics/blocked_visual.json</a:t>
+              <a:t>• Comando: uv run python run_gate.py metrics/healthy.json</a:t>
             </a:r>
           </a:p>
           <a:p>
@@ -4271,7 +4274,7 @@
                 </a:solidFill>
                 <a:latin typeface="Calibri"/>
               </a:rPr>
-              <a:t>• visual_diff_pixels enorme (banner broken de S9)</a:t>
+              <a:t>• Los 6 checks en true · failed: [] · passed: true</a:t>
             </a:r>
           </a:p>
           <a:p>
@@ -4287,7 +4290,7 @@
                 </a:solidFill>
                 <a:latin typeface="Calibri"/>
               </a:rPr>
-              <a:t>• failed: ["visual"] · exit 1</a:t>
+              <a:t>• Stderr: RELEASE: PASA</a:t>
             </a:r>
           </a:p>
           <a:p>
@@ -4303,7 +4306,7 @@
                 </a:solidFill>
                 <a:latin typeface="Calibri"/>
               </a:rPr>
-              <a:t>• El lab de clase incluye visual; el reto alumno no (a propósito)</a:t>
+              <a:t>• Ese es el merge feliz</a:t>
             </a:r>
           </a:p>
         </p:txBody>
@@ -4433,7 +4436,7 @@
                 </a:solidFill>
                 <a:latin typeface="Calibri"/>
               </a:rPr>
-              <a:t>metrics/blocked_many.json</a:t>
+              <a:t>mutation 0.80 &lt; 0.90</a:t>
             </a:r>
           </a:p>
         </p:txBody>
@@ -4467,7 +4470,7 @@
                 </a:solidFill>
                 <a:latin typeface="Calibri"/>
               </a:rPr>
-              <a:t>Sesión 10 · Release Gate · Cierre · Slide 13</a:t>
+              <a:t>Sesión 10 · Release Gate · Cierre · Slide 11</a:t>
             </a:r>
           </a:p>
         </p:txBody>
@@ -4506,7 +4509,7 @@
                 </a:solidFill>
                 <a:latin typeface="Calibri"/>
               </a:rPr>
-              <a:t>• Varios checks en rojo · lista failed completa</a:t>
+              <a:t>• Comando: uv run python run_gate.py metrics/blocked_mutation.json</a:t>
             </a:r>
           </a:p>
           <a:p>
@@ -4522,7 +4525,7 @@
                 </a:solidFill>
                 <a:latin typeface="Calibri"/>
               </a:rPr>
-              <a:t>• En un PR real: priorizá por riesgo (seguridad / a11y / perf)</a:t>
+              <a:t>• Solo mutation: false · exit 1</a:t>
             </a:r>
           </a:p>
           <a:p>
@@ -4538,7 +4541,7 @@
                 </a:solidFill>
                 <a:latin typeface="Calibri"/>
               </a:rPr>
-              <a:t>• El juez no prioriza: solo reporta; el equipo decide el orden de arreglo</a:t>
+              <a:t>• El resto puede estar verde: igual se bloquea</a:t>
             </a:r>
           </a:p>
         </p:txBody>
@@ -4668,7 +4671,7 @@
                 </a:solidFill>
                 <a:latin typeface="Calibri"/>
               </a:rPr>
-              <a:t>qa-release-gate.yml</a:t>
+              <a:t>Etapa 9 dentro del juez</a:t>
             </a:r>
           </a:p>
         </p:txBody>
@@ -4702,7 +4705,7 @@
                 </a:solidFill>
                 <a:latin typeface="Calibri"/>
               </a:rPr>
-              <a:t>Sesión 10 · Release Gate · Cierre · Slide 14</a:t>
+              <a:t>Sesión 10 · Release Gate · Cierre · Slide 12</a:t>
             </a:r>
           </a:p>
         </p:txBody>
@@ -4741,7 +4744,7 @@
                 </a:solidFill>
                 <a:latin typeface="Calibri"/>
               </a:rPr>
-              <a:t>• Workflow de ejemplo en workflows/</a:t>
+              <a:t>• Comando: uv run python run_gate.py metrics/blocked_visual.json</a:t>
             </a:r>
           </a:p>
           <a:p>
@@ -4757,7 +4760,7 @@
                 </a:solidFill>
                 <a:latin typeface="Calibri"/>
               </a:rPr>
-              <a:t>• Corre pytest del juez + demo sano + demo bloqueado</a:t>
+              <a:t>• visual_diff_pixels enorme (banner broken de S9)</a:t>
             </a:r>
           </a:p>
           <a:p>
@@ -4773,7 +4776,7 @@
                 </a:solidFill>
                 <a:latin typeface="Calibri"/>
               </a:rPr>
-              <a:t>• Pausá 10 · después: retos y cierre</a:t>
+              <a:t>• failed: ["visual"] · exit 1</a:t>
             </a:r>
           </a:p>
         </p:txBody>
@@ -4903,7 +4906,7 @@
                 </a:solidFill>
                 <a:latin typeface="Calibri"/>
               </a:rPr>
-              <a:t>Dónde practicar solos</a:t>
+              <a:t>metrics/blocked_many.json</a:t>
             </a:r>
           </a:p>
         </p:txBody>
@@ -4937,7 +4940,7 @@
                 </a:solidFill>
                 <a:latin typeface="Calibri"/>
               </a:rPr>
-              <a:t>Sesión 10 · Release Gate · Cierre · Slide 15</a:t>
+              <a:t>Sesión 10 · Release Gate · Cierre · Slide 13</a:t>
             </a:r>
           </a:p>
         </p:txBody>
@@ -4976,7 +4979,7 @@
                 </a:solidFill>
                 <a:latin typeface="Calibri"/>
               </a:rPr>
-              <a:t>• Teóricos 1 y 2 + práctico Release Gate: carpeta retos/</a:t>
+              <a:t>• Varios checks en rojo · lista failed completa</a:t>
             </a:r>
           </a:p>
           <a:p>
@@ -4992,7 +4995,7 @@
                 </a:solidFill>
                 <a:latin typeface="Calibri"/>
               </a:rPr>
-              <a:t>• Paquete: retos/RETOS_COMPLETOS.md</a:t>
+              <a:t>• En un PR real: priorizá por riesgo (seguridad / a11y / perf)</a:t>
             </a:r>
           </a:p>
           <a:p>
@@ -5008,23 +5011,7 @@
                 </a:solidFill>
                 <a:latin typeface="Calibri"/>
               </a:rPr>
-              <a:t>• Práctico GitHub: retos/reto-practico (14 tests)</a:t>
-            </a:r>
-          </a:p>
-          <a:p>
-            <a:pPr>
-              <a:spcAft>
-                <a:spcPts val="1000"/>
-              </a:spcAft>
-            </a:pPr>
-            <a:r>
-              <a:rPr sz="1800" b="0">
-                <a:solidFill>
-                  <a:srgbClr val="2C3E50"/>
-                </a:solidFill>
-                <a:latin typeface="Calibri"/>
-              </a:rPr>
-              <a:t>• El lab de hoy = juez completo con visual</a:t>
+              <a:t>• El juez no prioriza: solo reporta</a:t>
             </a:r>
           </a:p>
         </p:txBody>
@@ -5154,7 +5141,7 @@
                 </a:solidFill>
                 <a:latin typeface="Calibri"/>
               </a:rPr>
-              <a:t>Cinco preguntas (el instructor las responde en voz alta)</a:t>
+              <a:t>qa-release-gate.yml</a:t>
             </a:r>
           </a:p>
         </p:txBody>
@@ -5188,7 +5175,7 @@
                 </a:solidFill>
                 <a:latin typeface="Calibri"/>
               </a:rPr>
-              <a:t>Sesión 10 · Release Gate · Cierre · Slide 16</a:t>
+              <a:t>Sesión 10 · Release Gate · Cierre · Slide 14</a:t>
             </a:r>
           </a:p>
         </p:txBody>
@@ -5227,7 +5214,7 @@
                 </a:solidFill>
                 <a:latin typeface="Calibri"/>
               </a:rPr>
-              <a:t>• ¿Cobertura = calidad? No.</a:t>
+              <a:t>• Workflow de ejemplo en workflows/</a:t>
             </a:r>
           </a:p>
           <a:p>
@@ -5243,7 +5230,7 @@
                 </a:solidFill>
                 <a:latin typeface="Calibri"/>
               </a:rPr>
-              <a:t>• ¿WARN de ZAP bloquea? No.</a:t>
+              <a:t>• Corre pytest del juez + demo sano + demo bloqueado</a:t>
             </a:r>
           </a:p>
           <a:p>
@@ -5259,39 +5246,7 @@
                 </a:solidFill>
                 <a:latin typeface="Calibri"/>
               </a:rPr>
-              <a:t>• ¿Mutante equivalente se puede matar? No.</a:t>
-            </a:r>
-          </a:p>
-          <a:p>
-            <a:pPr>
-              <a:spcAft>
-                <a:spcPts val="1000"/>
-              </a:spcAft>
-            </a:pPr>
-            <a:r>
-              <a:rPr sz="1800" b="0">
-                <a:solidFill>
-                  <a:srgbClr val="2C3E50"/>
-                </a:solidFill>
-                <a:latin typeface="Calibri"/>
-              </a:rPr>
-              <a:t>• ¿Gate visual con broken=1 debe quedar verde? No.</a:t>
-            </a:r>
-          </a:p>
-          <a:p>
-            <a:pPr>
-              <a:spcAft>
-                <a:spcPts val="1000"/>
-              </a:spcAft>
-            </a:pPr>
-            <a:r>
-              <a:rPr sz="1800" b="0">
-                <a:solidFill>
-                  <a:srgbClr val="2C3E50"/>
-                </a:solidFill>
-                <a:latin typeface="Calibri"/>
-              </a:rPr>
-              <a:t>• ¿Appium fue hands-on obligatorio? No: mapa; Playwright sí.</a:t>
+              <a:t>• Pausá 10 · Bloque C: un check a la vez</a:t>
             </a:r>
           </a:p>
         </p:txBody>
@@ -5421,7 +5376,7 @@
                 </a:solidFill>
                 <a:latin typeface="Calibri"/>
               </a:rPr>
-              <a:t>Tres frases para llevarse</a:t>
+              <a:t>Cada JSON = una sesión</a:t>
             </a:r>
           </a:p>
         </p:txBody>
@@ -5455,7 +5410,7 @@
                 </a:solidFill>
                 <a:latin typeface="Calibri"/>
               </a:rPr>
-              <a:t>Sesión 10 · Release Gate · Cierre · Slide 17</a:t>
+              <a:t>Sesión 10 · Release Gate · Cierre · Slide 15</a:t>
             </a:r>
           </a:p>
         </p:txBody>
@@ -5494,7 +5449,7 @@
                 </a:solidFill>
                 <a:latin typeface="Calibri"/>
               </a:rPr>
-              <a:t>• Qué usaría mañana en el trabajo</a:t>
+              <a:t>• blocked_pass_rate.json → S4/S5 · blocked_p95.json → S6</a:t>
             </a:r>
           </a:p>
           <a:p>
@@ -5510,7 +5465,7 @@
                 </a:solidFill>
                 <a:latin typeface="Calibri"/>
               </a:rPr>
-              <a:t>• Qué les costó más (Docker, mutación, ZAP, visual…)</a:t>
+              <a:t>• blocked_zap.json / blocked_a11y.json → S7</a:t>
             </a:r>
           </a:p>
           <a:p>
@@ -5526,7 +5481,7 @@
                 </a:solidFill>
                 <a:latin typeface="Calibri"/>
               </a:rPr>
-              <a:t>• Qué umbral negociarían primero con el equipo</a:t>
+              <a:t>• blocked_mutation.json → S8 · blocked_visual.json → S9</a:t>
             </a:r>
           </a:p>
           <a:p>
@@ -5542,7 +5497,7 @@
                 </a:solidFill>
                 <a:latin typeface="Calibri"/>
               </a:rPr>
-              <a:t>• El instructor modela una respuesta; no hace ronda obligatoria</a:t>
+              <a:t>• Corré uno por uno y leé failed: ["…"]</a:t>
             </a:r>
           </a:p>
         </p:txBody>
@@ -5672,7 +5627,7 @@
                 </a:solidFill>
                 <a:latin typeface="Calibri"/>
               </a:rPr>
-              <a:t>Gracias</a:t>
+              <a:t>Arreglar la métrica, no el umbral</a:t>
             </a:r>
           </a:p>
         </p:txBody>
@@ -5706,7 +5661,7 @@
                 </a:solidFill>
                 <a:latin typeface="Calibri"/>
               </a:rPr>
-              <a:t>Sesión 10 · Release Gate · Cierre · Slide 18</a:t>
+              <a:t>Sesión 10 · Release Gate · Cierre · Slide 16</a:t>
             </a:r>
           </a:p>
         </p:txBody>
@@ -5745,7 +5700,7 @@
                 </a:solidFill>
                 <a:latin typeface="Calibri"/>
               </a:rPr>
-              <a:t>• Construyeron una puerta de 9 etapas + un juez</a:t>
+              <a:t>• Abrí metrics/blocked_mutation.json</a:t>
             </a:r>
           </a:p>
           <a:p>
@@ -5761,7 +5716,7 @@
                 </a:solidFill>
                 <a:latin typeface="Calibri"/>
               </a:rPr>
-              <a:t>• Mantenerla es trabajo continuo (umbrales, baselines, flaky)</a:t>
+              <a:t>• Cambiá 0.80 → 0.96 · guardá · volvé a correr el gate</a:t>
             </a:r>
           </a:p>
           <a:p>
@@ -5777,7 +5732,7 @@
                 </a:solidFill>
                 <a:latin typeface="Calibri"/>
               </a:rPr>
-              <a:t>• Frase final: el verde no es una opinión</a:t>
+              <a:t>• exit 0 — el release pasa sin tocar THRESHOLDS</a:t>
             </a:r>
           </a:p>
           <a:p>
@@ -5793,7 +5748,23 @@
                 </a:solidFill>
                 <a:latin typeface="Calibri"/>
               </a:rPr>
-              <a:t>• Certificación 3 — cerrada en contenido</a:t>
+              <a:t>• Al final: git checkout -- metrics/blocked_mutation.json (lab limpio)</a:t>
+            </a:r>
+          </a:p>
+          <a:p>
+            <a:pPr>
+              <a:spcAft>
+                <a:spcPts val="1000"/>
+              </a:spcAft>
+            </a:pPr>
+            <a:r>
+              <a:rPr sz="1800" b="0">
+                <a:solidFill>
+                  <a:srgbClr val="2C3E50"/>
+                </a:solidFill>
+                <a:latin typeface="Calibri"/>
+              </a:rPr>
+              <a:t>• Misma lógica que arreglar tests, perf o visual en un PR real</a:t>
             </a:r>
           </a:p>
         </p:txBody>
@@ -6012,7 +5983,7 @@
                 </a:solidFill>
                 <a:latin typeface="Calibri"/>
               </a:rPr>
-              <a:t>• B (40): lab release-gate (sano / bloqueado)</a:t>
+              <a:t>• B (40): lab release-gate (sano / bloqueado / many)</a:t>
             </a:r>
           </a:p>
           <a:p>
@@ -6028,7 +5999,7 @@
                 </a:solidFill>
                 <a:latin typeface="Calibri"/>
               </a:rPr>
-              <a:t>• C (20): retos · evaluación · retrospectiva</a:t>
+              <a:t>• C (20): un check rojo a la vez · desbloquear · forzar fallos · arco completo</a:t>
             </a:r>
           </a:p>
           <a:p>
@@ -6045,6 +6016,775 @@
                 <a:latin typeface="Calibri"/>
               </a:rPr>
               <a:t>• Dos pausas de 10 minutos</a:t>
+            </a:r>
+          </a:p>
+        </p:txBody>
+      </p:sp>
+      <p:sp>
+        <p:nvSpPr>
+          <p:cNvPr id="6" name="TextBox 5"/>
+          <p:cNvSpPr txBox="1"/>
+          <p:nvPr/>
+        </p:nvSpPr>
+        <p:spPr>
+          <a:xfrm>
+            <a:off x="548640" y="6446520"/>
+            <a:ext cx="11064240" cy="274320"/>
+          </a:xfrm>
+          <a:prstGeom prst="rect">
+            <a:avLst/>
+          </a:prstGeom>
+          <a:noFill/>
+        </p:spPr>
+        <p:txBody>
+          <a:bodyPr wrap="none">
+            <a:spAutoFit/>
+          </a:bodyPr>
+          <a:lstStyle/>
+          <a:p>
+            <a:pPr algn="r"/>
+            <a:r>
+              <a:rPr sz="1000" b="0">
+                <a:solidFill>
+                  <a:srgbClr val="7F8C8D"/>
+                </a:solidFill>
+                <a:latin typeface="Calibri"/>
+              </a:rPr>
+              <a:t>Certificación 3 — APIs, Performance y Seguridad</a:t>
+            </a:r>
+          </a:p>
+        </p:txBody>
+      </p:sp>
+    </p:spTree>
+  </p:cSld>
+  <p:clrMapOvr>
+    <a:masterClrMapping/>
+  </p:clrMapOvr>
+</p:sld>
+</file>
+
+<file path=ppt/slides/slide20.xml><?xml version="1.0" encoding="utf-8"?>
+<p:sld xmlns:a="http://schemas.openxmlformats.org/drawingml/2006/main" xmlns:p="http://schemas.openxmlformats.org/presentationml/2006/main" xmlns:r="http://schemas.openxmlformats.org/officeDocument/2006/relationships">
+  <p:cSld>
+    <p:spTree>
+      <p:nvGrpSpPr>
+        <p:cNvPr id="1" name=""/>
+        <p:cNvGrpSpPr/>
+        <p:nvPr/>
+      </p:nvGrpSpPr>
+      <p:grpSpPr/>
+      <p:sp>
+        <p:nvSpPr>
+          <p:cNvPr id="2" name="Rectangle 1"/>
+          <p:cNvSpPr/>
+          <p:nvPr/>
+        </p:nvSpPr>
+        <p:spPr>
+          <a:xfrm>
+            <a:off x="0" y="0"/>
+            <a:ext cx="12191695" cy="146304"/>
+          </a:xfrm>
+          <a:prstGeom prst="rect">
+            <a:avLst/>
+          </a:prstGeom>
+          <a:solidFill>
+            <a:srgbClr val="0E7C7B"/>
+          </a:solidFill>
+          <a:ln>
+            <a:noFill/>
+          </a:ln>
+        </p:spPr>
+        <p:style>
+          <a:lnRef idx="1">
+            <a:schemeClr val="accent1"/>
+          </a:lnRef>
+          <a:fillRef idx="3">
+            <a:schemeClr val="accent1"/>
+          </a:fillRef>
+          <a:effectRef idx="2">
+            <a:schemeClr val="accent1"/>
+          </a:effectRef>
+          <a:fontRef idx="minor">
+            <a:schemeClr val="lt1"/>
+          </a:fontRef>
+        </p:style>
+        <p:txBody>
+          <a:bodyPr rtlCol="0" anchor="ctr"/>
+          <a:lstStyle/>
+          <a:p>
+            <a:pPr algn="ctr"/>
+          </a:p>
+        </p:txBody>
+      </p:sp>
+      <p:sp>
+        <p:nvSpPr>
+          <p:cNvPr id="3" name="TextBox 2"/>
+          <p:cNvSpPr txBox="1"/>
+          <p:nvPr/>
+        </p:nvSpPr>
+        <p:spPr>
+          <a:xfrm>
+            <a:off x="548640" y="320040"/>
+            <a:ext cx="11064240" cy="914400"/>
+          </a:xfrm>
+          <a:prstGeom prst="rect">
+            <a:avLst/>
+          </a:prstGeom>
+          <a:noFill/>
+        </p:spPr>
+        <p:txBody>
+          <a:bodyPr wrap="square">
+            <a:spAutoFit/>
+          </a:bodyPr>
+          <a:lstStyle/>
+          <a:p>
+            <a:r>
+              <a:rPr sz="2800" b="1">
+                <a:solidFill>
+                  <a:srgbClr val="1B2A4A"/>
+                </a:solidFill>
+                <a:latin typeface="Calibri"/>
+              </a:rPr>
+              <a:t>Tres fallos distintos (no es lo mismo)</a:t>
+            </a:r>
+          </a:p>
+        </p:txBody>
+      </p:sp>
+      <p:sp>
+        <p:nvSpPr>
+          <p:cNvPr id="4" name="TextBox 3"/>
+          <p:cNvSpPr txBox="1"/>
+          <p:nvPr/>
+        </p:nvSpPr>
+        <p:spPr>
+          <a:xfrm>
+            <a:off x="548640" y="1143000"/>
+            <a:ext cx="11064240" cy="274320"/>
+          </a:xfrm>
+          <a:prstGeom prst="rect">
+            <a:avLst/>
+          </a:prstGeom>
+          <a:noFill/>
+        </p:spPr>
+        <p:txBody>
+          <a:bodyPr wrap="none">
+            <a:spAutoFit/>
+          </a:bodyPr>
+          <a:lstStyle/>
+          <a:p>
+            <a:r>
+              <a:rPr sz="1200" b="0">
+                <a:solidFill>
+                  <a:srgbClr val="0E7C7B"/>
+                </a:solidFill>
+                <a:latin typeface="Calibri"/>
+              </a:rPr>
+              <a:t>Sesión 10 · Release Gate · Cierre · Slide 16b</a:t>
+            </a:r>
+          </a:p>
+        </p:txBody>
+      </p:sp>
+      <p:sp>
+        <p:nvSpPr>
+          <p:cNvPr id="5" name="TextBox 4"/>
+          <p:cNvSpPr txBox="1"/>
+          <p:nvPr/>
+        </p:nvSpPr>
+        <p:spPr>
+          <a:xfrm>
+            <a:off x="640080" y="1554480"/>
+            <a:ext cx="10881360" cy="4754880"/>
+          </a:xfrm>
+          <a:prstGeom prst="rect">
+            <a:avLst/>
+          </a:prstGeom>
+          <a:noFill/>
+        </p:spPr>
+        <p:txBody>
+          <a:bodyPr wrap="square">
+            <a:spAutoFit/>
+          </a:bodyPr>
+          <a:lstStyle/>
+          <a:p>
+            <a:pPr>
+              <a:spcAft>
+                <a:spcPts val="1000"/>
+              </a:spcAft>
+            </a:pPr>
+            <a:r>
+              <a:rPr sz="1800" b="0">
+                <a:solidFill>
+                  <a:srgbClr val="2C3E50"/>
+                </a:solidFill>
+                <a:latin typeface="Calibri"/>
+              </a:rPr>
+              <a:t>• demos/incomplete.json → CLI: JSON incompleto (no evalúa)</a:t>
+            </a:r>
+          </a:p>
+          <a:p>
+            <a:pPr>
+              <a:spcAft>
+                <a:spcPts val="1000"/>
+              </a:spcAft>
+            </a:pPr>
+            <a:r>
+              <a:rPr sz="1800" b="0">
+                <a:solidFill>
+                  <a:srgbClr val="2C3E50"/>
+                </a:solidFill>
+                <a:latin typeface="Calibri"/>
+              </a:rPr>
+              <a:t>• demos/invalid.json → CLI: JSON invalido (sintaxis)</a:t>
+            </a:r>
+          </a:p>
+          <a:p>
+            <a:pPr>
+              <a:spcAft>
+                <a:spcPts val="1000"/>
+              </a:spcAft>
+            </a:pPr>
+            <a:r>
+              <a:rPr sz="1800" b="0">
+                <a:solidFill>
+                  <a:srgbClr val="2C3E50"/>
+                </a:solidFill>
+                <a:latin typeface="Calibri"/>
+              </a:rPr>
+              <a:t>• Fixture que miente → pytest AssertionError en rojo</a:t>
+            </a:r>
+          </a:p>
+          <a:p>
+            <a:pPr>
+              <a:spcAft>
+                <a:spcPts val="1000"/>
+              </a:spcAft>
+            </a:pPr>
+            <a:r>
+              <a:rPr sz="1800" b="0">
+                <a:solidFill>
+                  <a:srgbClr val="2C3E50"/>
+                </a:solidFill>
+                <a:latin typeface="Calibri"/>
+              </a:rPr>
+              <a:t>• Comando: uv run python scripts/demo_force_fail.py</a:t>
+            </a:r>
+          </a:p>
+          <a:p>
+            <a:pPr>
+              <a:spcAft>
+                <a:spcPts val="1000"/>
+              </a:spcAft>
+            </a:pPr>
+            <a:r>
+              <a:rPr sz="1800" b="0">
+                <a:solidFill>
+                  <a:srgbClr val="2C3E50"/>
+                </a:solidFill>
+                <a:latin typeface="Calibri"/>
+              </a:rPr>
+              <a:t>• blocked_*.json = métrica bajo umbral (negocio) ≠ basura de entrada</a:t>
+            </a:r>
+          </a:p>
+        </p:txBody>
+      </p:sp>
+      <p:sp>
+        <p:nvSpPr>
+          <p:cNvPr id="6" name="TextBox 5"/>
+          <p:cNvSpPr txBox="1"/>
+          <p:nvPr/>
+        </p:nvSpPr>
+        <p:spPr>
+          <a:xfrm>
+            <a:off x="548640" y="6446520"/>
+            <a:ext cx="11064240" cy="274320"/>
+          </a:xfrm>
+          <a:prstGeom prst="rect">
+            <a:avLst/>
+          </a:prstGeom>
+          <a:noFill/>
+        </p:spPr>
+        <p:txBody>
+          <a:bodyPr wrap="none">
+            <a:spAutoFit/>
+          </a:bodyPr>
+          <a:lstStyle/>
+          <a:p>
+            <a:pPr algn="r"/>
+            <a:r>
+              <a:rPr sz="1000" b="0">
+                <a:solidFill>
+                  <a:srgbClr val="7F8C8D"/>
+                </a:solidFill>
+                <a:latin typeface="Calibri"/>
+              </a:rPr>
+              <a:t>Certificación 3 — APIs, Performance y Seguridad</a:t>
+            </a:r>
+          </a:p>
+        </p:txBody>
+      </p:sp>
+    </p:spTree>
+  </p:cSld>
+  <p:clrMapOvr>
+    <a:masterClrMapping/>
+  </p:clrMapOvr>
+</p:sld>
+</file>
+
+<file path=ppt/slides/slide21.xml><?xml version="1.0" encoding="utf-8"?>
+<p:sld xmlns:a="http://schemas.openxmlformats.org/drawingml/2006/main" xmlns:p="http://schemas.openxmlformats.org/presentationml/2006/main" xmlns:r="http://schemas.openxmlformats.org/officeDocument/2006/relationships">
+  <p:cSld>
+    <p:spTree>
+      <p:nvGrpSpPr>
+        <p:cNvPr id="1" name=""/>
+        <p:cNvGrpSpPr/>
+        <p:nvPr/>
+      </p:nvGrpSpPr>
+      <p:grpSpPr/>
+      <p:sp>
+        <p:nvSpPr>
+          <p:cNvPr id="2" name="Rectangle 1"/>
+          <p:cNvSpPr/>
+          <p:nvPr/>
+        </p:nvSpPr>
+        <p:spPr>
+          <a:xfrm>
+            <a:off x="0" y="0"/>
+            <a:ext cx="12191695" cy="146304"/>
+          </a:xfrm>
+          <a:prstGeom prst="rect">
+            <a:avLst/>
+          </a:prstGeom>
+          <a:solidFill>
+            <a:srgbClr val="0E7C7B"/>
+          </a:solidFill>
+          <a:ln>
+            <a:noFill/>
+          </a:ln>
+        </p:spPr>
+        <p:style>
+          <a:lnRef idx="1">
+            <a:schemeClr val="accent1"/>
+          </a:lnRef>
+          <a:fillRef idx="3">
+            <a:schemeClr val="accent1"/>
+          </a:fillRef>
+          <a:effectRef idx="2">
+            <a:schemeClr val="accent1"/>
+          </a:effectRef>
+          <a:fontRef idx="minor">
+            <a:schemeClr val="lt1"/>
+          </a:fontRef>
+        </p:style>
+        <p:txBody>
+          <a:bodyPr rtlCol="0" anchor="ctr"/>
+          <a:lstStyle/>
+          <a:p>
+            <a:pPr algn="ctr"/>
+          </a:p>
+        </p:txBody>
+      </p:sp>
+      <p:sp>
+        <p:nvSpPr>
+          <p:cNvPr id="3" name="TextBox 2"/>
+          <p:cNvSpPr txBox="1"/>
+          <p:nvPr/>
+        </p:nvSpPr>
+        <p:spPr>
+          <a:xfrm>
+            <a:off x="548640" y="320040"/>
+            <a:ext cx="11064240" cy="914400"/>
+          </a:xfrm>
+          <a:prstGeom prst="rect">
+            <a:avLst/>
+          </a:prstGeom>
+          <a:noFill/>
+        </p:spPr>
+        <p:txBody>
+          <a:bodyPr wrap="square">
+            <a:spAutoFit/>
+          </a:bodyPr>
+          <a:lstStyle/>
+          <a:p>
+            <a:r>
+              <a:rPr sz="2800" b="1">
+                <a:solidFill>
+                  <a:srgbClr val="1B2A4A"/>
+                </a:solidFill>
+                <a:latin typeface="Calibri"/>
+              </a:rPr>
+              <a:t>Un comando, todos los escenarios</a:t>
+            </a:r>
+          </a:p>
+        </p:txBody>
+      </p:sp>
+      <p:sp>
+        <p:nvSpPr>
+          <p:cNvPr id="4" name="TextBox 3"/>
+          <p:cNvSpPr txBox="1"/>
+          <p:nvPr/>
+        </p:nvSpPr>
+        <p:spPr>
+          <a:xfrm>
+            <a:off x="548640" y="1143000"/>
+            <a:ext cx="11064240" cy="274320"/>
+          </a:xfrm>
+          <a:prstGeom prst="rect">
+            <a:avLst/>
+          </a:prstGeom>
+          <a:noFill/>
+        </p:spPr>
+        <p:txBody>
+          <a:bodyPr wrap="none">
+            <a:spAutoFit/>
+          </a:bodyPr>
+          <a:lstStyle/>
+          <a:p>
+            <a:r>
+              <a:rPr sz="1200" b="0">
+                <a:solidFill>
+                  <a:srgbClr val="0E7C7B"/>
+                </a:solidFill>
+                <a:latin typeface="Calibri"/>
+              </a:rPr>
+              <a:t>Sesión 10 · Release Gate · Cierre · Slide 17</a:t>
+            </a:r>
+          </a:p>
+        </p:txBody>
+      </p:sp>
+      <p:sp>
+        <p:nvSpPr>
+          <p:cNvPr id="5" name="TextBox 4"/>
+          <p:cNvSpPr txBox="1"/>
+          <p:nvPr/>
+        </p:nvSpPr>
+        <p:spPr>
+          <a:xfrm>
+            <a:off x="640080" y="1554480"/>
+            <a:ext cx="10881360" cy="4754880"/>
+          </a:xfrm>
+          <a:prstGeom prst="rect">
+            <a:avLst/>
+          </a:prstGeom>
+          <a:noFill/>
+        </p:spPr>
+        <p:txBody>
+          <a:bodyPr wrap="square">
+            <a:spAutoFit/>
+          </a:bodyPr>
+          <a:lstStyle/>
+          <a:p>
+            <a:pPr>
+              <a:spcAft>
+                <a:spcPts val="1000"/>
+              </a:spcAft>
+            </a:pPr>
+            <a:r>
+              <a:rPr sz="1800" b="0">
+                <a:solidFill>
+                  <a:srgbClr val="2C3E50"/>
+                </a:solidFill>
+                <a:latin typeface="Calibri"/>
+              </a:rPr>
+              <a:t>• uv run python scripts/run_all_demos.py</a:t>
+            </a:r>
+          </a:p>
+          <a:p>
+            <a:pPr>
+              <a:spcAft>
+                <a:spcPts val="1000"/>
+              </a:spcAft>
+            </a:pPr>
+            <a:r>
+              <a:rPr sz="1800" b="0">
+                <a:solidFill>
+                  <a:srgbClr val="2C3E50"/>
+                </a:solidFill>
+                <a:latin typeface="Calibri"/>
+              </a:rPr>
+              <a:t>• pytest + healthy + cada bloqueo + many</a:t>
+            </a:r>
+          </a:p>
+          <a:p>
+            <a:pPr>
+              <a:spcAft>
+                <a:spcPts val="1000"/>
+              </a:spcAft>
+            </a:pPr>
+            <a:r>
+              <a:rPr sz="1800" b="0">
+                <a:solidFill>
+                  <a:srgbClr val="2C3E50"/>
+                </a:solidFill>
+                <a:latin typeface="Calibri"/>
+              </a:rPr>
+              <a:t>• Task: task test:gate:demos</a:t>
+            </a:r>
+          </a:p>
+          <a:p>
+            <a:pPr>
+              <a:spcAft>
+                <a:spcPts val="1000"/>
+              </a:spcAft>
+            </a:pPr>
+            <a:r>
+              <a:rPr sz="1800" b="0">
+                <a:solidFill>
+                  <a:srgbClr val="2C3E50"/>
+                </a:solidFill>
+                <a:latin typeface="Calibri"/>
+              </a:rPr>
+              <a:t>• Si algo falla, el script te dice cuál escenario</a:t>
+            </a:r>
+          </a:p>
+        </p:txBody>
+      </p:sp>
+      <p:sp>
+        <p:nvSpPr>
+          <p:cNvPr id="6" name="TextBox 5"/>
+          <p:cNvSpPr txBox="1"/>
+          <p:nvPr/>
+        </p:nvSpPr>
+        <p:spPr>
+          <a:xfrm>
+            <a:off x="548640" y="6446520"/>
+            <a:ext cx="11064240" cy="274320"/>
+          </a:xfrm>
+          <a:prstGeom prst="rect">
+            <a:avLst/>
+          </a:prstGeom>
+          <a:noFill/>
+        </p:spPr>
+        <p:txBody>
+          <a:bodyPr wrap="none">
+            <a:spAutoFit/>
+          </a:bodyPr>
+          <a:lstStyle/>
+          <a:p>
+            <a:pPr algn="r"/>
+            <a:r>
+              <a:rPr sz="1000" b="0">
+                <a:solidFill>
+                  <a:srgbClr val="7F8C8D"/>
+                </a:solidFill>
+                <a:latin typeface="Calibri"/>
+              </a:rPr>
+              <a:t>Certificación 3 — APIs, Performance y Seguridad</a:t>
+            </a:r>
+          </a:p>
+        </p:txBody>
+      </p:sp>
+    </p:spTree>
+  </p:cSld>
+  <p:clrMapOvr>
+    <a:masterClrMapping/>
+  </p:clrMapOvr>
+</p:sld>
+</file>
+
+<file path=ppt/slides/slide22.xml><?xml version="1.0" encoding="utf-8"?>
+<p:sld xmlns:a="http://schemas.openxmlformats.org/drawingml/2006/main" xmlns:p="http://schemas.openxmlformats.org/presentationml/2006/main" xmlns:r="http://schemas.openxmlformats.org/officeDocument/2006/relationships">
+  <p:cSld>
+    <p:spTree>
+      <p:nvGrpSpPr>
+        <p:cNvPr id="1" name=""/>
+        <p:cNvGrpSpPr/>
+        <p:nvPr/>
+      </p:nvGrpSpPr>
+      <p:grpSpPr/>
+      <p:sp>
+        <p:nvSpPr>
+          <p:cNvPr id="2" name="Rectangle 1"/>
+          <p:cNvSpPr/>
+          <p:nvPr/>
+        </p:nvSpPr>
+        <p:spPr>
+          <a:xfrm>
+            <a:off x="0" y="0"/>
+            <a:ext cx="12191695" cy="146304"/>
+          </a:xfrm>
+          <a:prstGeom prst="rect">
+            <a:avLst/>
+          </a:prstGeom>
+          <a:solidFill>
+            <a:srgbClr val="0E7C7B"/>
+          </a:solidFill>
+          <a:ln>
+            <a:noFill/>
+          </a:ln>
+        </p:spPr>
+        <p:style>
+          <a:lnRef idx="1">
+            <a:schemeClr val="accent1"/>
+          </a:lnRef>
+          <a:fillRef idx="3">
+            <a:schemeClr val="accent1"/>
+          </a:fillRef>
+          <a:effectRef idx="2">
+            <a:schemeClr val="accent1"/>
+          </a:effectRef>
+          <a:fontRef idx="minor">
+            <a:schemeClr val="lt1"/>
+          </a:fontRef>
+        </p:style>
+        <p:txBody>
+          <a:bodyPr rtlCol="0" anchor="ctr"/>
+          <a:lstStyle/>
+          <a:p>
+            <a:pPr algn="ctr"/>
+          </a:p>
+        </p:txBody>
+      </p:sp>
+      <p:sp>
+        <p:nvSpPr>
+          <p:cNvPr id="3" name="TextBox 2"/>
+          <p:cNvSpPr txBox="1"/>
+          <p:nvPr/>
+        </p:nvSpPr>
+        <p:spPr>
+          <a:xfrm>
+            <a:off x="548640" y="320040"/>
+            <a:ext cx="11064240" cy="914400"/>
+          </a:xfrm>
+          <a:prstGeom prst="rect">
+            <a:avLst/>
+          </a:prstGeom>
+          <a:noFill/>
+        </p:spPr>
+        <p:txBody>
+          <a:bodyPr wrap="square">
+            <a:spAutoFit/>
+          </a:bodyPr>
+          <a:lstStyle/>
+          <a:p>
+            <a:r>
+              <a:rPr sz="2800" b="1">
+                <a:solidFill>
+                  <a:srgbClr val="1B2A4A"/>
+                </a:solidFill>
+                <a:latin typeface="Calibri"/>
+              </a:rPr>
+              <a:t>Gracias</a:t>
+            </a:r>
+          </a:p>
+        </p:txBody>
+      </p:sp>
+      <p:sp>
+        <p:nvSpPr>
+          <p:cNvPr id="4" name="TextBox 3"/>
+          <p:cNvSpPr txBox="1"/>
+          <p:nvPr/>
+        </p:nvSpPr>
+        <p:spPr>
+          <a:xfrm>
+            <a:off x="548640" y="1143000"/>
+            <a:ext cx="11064240" cy="274320"/>
+          </a:xfrm>
+          <a:prstGeom prst="rect">
+            <a:avLst/>
+          </a:prstGeom>
+          <a:noFill/>
+        </p:spPr>
+        <p:txBody>
+          <a:bodyPr wrap="none">
+            <a:spAutoFit/>
+          </a:bodyPr>
+          <a:lstStyle/>
+          <a:p>
+            <a:r>
+              <a:rPr sz="1200" b="0">
+                <a:solidFill>
+                  <a:srgbClr val="0E7C7B"/>
+                </a:solidFill>
+                <a:latin typeface="Calibri"/>
+              </a:rPr>
+              <a:t>Sesión 10 · Release Gate · Cierre · Slide 18</a:t>
+            </a:r>
+          </a:p>
+        </p:txBody>
+      </p:sp>
+      <p:sp>
+        <p:nvSpPr>
+          <p:cNvPr id="5" name="TextBox 4"/>
+          <p:cNvSpPr txBox="1"/>
+          <p:nvPr/>
+        </p:nvSpPr>
+        <p:spPr>
+          <a:xfrm>
+            <a:off x="640080" y="1554480"/>
+            <a:ext cx="10881360" cy="4754880"/>
+          </a:xfrm>
+          <a:prstGeom prst="rect">
+            <a:avLst/>
+          </a:prstGeom>
+          <a:noFill/>
+        </p:spPr>
+        <p:txBody>
+          <a:bodyPr wrap="square">
+            <a:spAutoFit/>
+          </a:bodyPr>
+          <a:lstStyle/>
+          <a:p>
+            <a:pPr>
+              <a:spcAft>
+                <a:spcPts val="1000"/>
+              </a:spcAft>
+            </a:pPr>
+            <a:r>
+              <a:rPr sz="1800" b="0">
+                <a:solidFill>
+                  <a:srgbClr val="2C3E50"/>
+                </a:solidFill>
+                <a:latin typeface="Calibri"/>
+              </a:rPr>
+              <a:t>• Construyeron una puerta de 9 etapas + un juez</a:t>
+            </a:r>
+          </a:p>
+          <a:p>
+            <a:pPr>
+              <a:spcAft>
+                <a:spcPts val="1000"/>
+              </a:spcAft>
+            </a:pPr>
+            <a:r>
+              <a:rPr sz="1800" b="0">
+                <a:solidFill>
+                  <a:srgbClr val="2C3E50"/>
+                </a:solidFill>
+                <a:latin typeface="Calibri"/>
+              </a:rPr>
+              <a:t>• Mantenerla es trabajo continuo (umbrales, baselines, flaky)</a:t>
+            </a:r>
+          </a:p>
+          <a:p>
+            <a:pPr>
+              <a:spcAft>
+                <a:spcPts val="1000"/>
+              </a:spcAft>
+            </a:pPr>
+            <a:r>
+              <a:rPr sz="1800" b="0">
+                <a:solidFill>
+                  <a:srgbClr val="2C3E50"/>
+                </a:solidFill>
+                <a:latin typeface="Calibri"/>
+              </a:rPr>
+              <a:t>• Frase final: el verde no es una opinión</a:t>
+            </a:r>
+          </a:p>
+          <a:p>
+            <a:pPr>
+              <a:spcAft>
+                <a:spcPts val="1000"/>
+              </a:spcAft>
+            </a:pPr>
+            <a:r>
+              <a:rPr sz="1800" b="0">
+                <a:solidFill>
+                  <a:srgbClr val="2C3E50"/>
+                </a:solidFill>
+                <a:latin typeface="Calibri"/>
+              </a:rPr>
+              <a:t>• Certificación 3 — contenido cerrado</a:t>
             </a:r>
           </a:p>
         </p:txBody>
@@ -6549,6 +7289,22 @@
               <a:t>• Si un check falla → el release no mergea</a:t>
             </a:r>
           </a:p>
+          <a:p>
+            <a:pPr>
+              <a:spcAft>
+                <a:spcPts val="1000"/>
+              </a:spcAft>
+            </a:pPr>
+            <a:r>
+              <a:rPr sz="1800" b="0">
+                <a:solidFill>
+                  <a:srgbClr val="2C3E50"/>
+                </a:solidFill>
+                <a:latin typeface="Calibri"/>
+              </a:rPr>
+              <a:t>• Gate ≠ dashboard: el dashboard informa, el gate decide</a:t>
+            </a:r>
+          </a:p>
         </p:txBody>
       </p:sp>
       <p:sp>
@@ -6676,7 +7432,7 @@
                 </a:solidFill>
                 <a:latin typeface="Calibri"/>
               </a:rPr>
-              <a:t>Los números que ya conocen</a:t>
+              <a:t>Entrada y salida del juez</a:t>
             </a:r>
           </a:p>
         </p:txBody>
@@ -6710,7 +7466,7 @@
                 </a:solidFill>
                 <a:latin typeface="Calibri"/>
               </a:rPr>
-              <a:t>Sesión 10 · Release Gate · Cierre · Slide 5</a:t>
+              <a:t>Sesión 10 · Release Gate · Cierre · Slide 4b</a:t>
             </a:r>
           </a:p>
         </p:txBody>
@@ -6749,7 +7505,7 @@
                 </a:solidFill>
                 <a:latin typeface="Calibri"/>
               </a:rPr>
-              <a:t>• pass_rate ≥ 0.95 · p95 ≤ 500 ms</a:t>
+              <a:t>• Entrada: 6 campos, ninguno opcional</a:t>
             </a:r>
           </a:p>
           <a:p>
@@ -6765,7 +7521,7 @@
                 </a:solidFill>
                 <a:latin typeface="Calibri"/>
               </a:rPr>
-              <a:t>• ZAP fail_new ≤ 0 (WARN no bloquea)</a:t>
+              <a:t>• pass_rate (ratio) · p95_ms (ms) · zap_fail_new (conteo)</a:t>
             </a:r>
           </a:p>
           <a:p>
@@ -6781,7 +7537,7 @@
                 </a:solidFill>
                 <a:latin typeface="Calibri"/>
               </a:rPr>
-              <a:t>• mutation ≥ 0.90 · a11y critical ≤ 0</a:t>
+              <a:t>• mutation_score (ratio) · a11y_critical (conteo) · visual_diff_pixels (px)</a:t>
             </a:r>
           </a:p>
           <a:p>
@@ -6797,7 +7553,7 @@
                 </a:solidFill>
                 <a:latin typeface="Calibri"/>
               </a:rPr>
-              <a:t>• visual_diff ≤ 120 px (S9)</a:t>
+              <a:t>• Salida: checks + failed + passed + eco de thresholds</a:t>
             </a:r>
           </a:p>
           <a:p>
@@ -6813,7 +7569,7 @@
                 </a:solidFill>
                 <a:latin typeface="Calibri"/>
               </a:rPr>
-              <a:t>• En el umbral exacto: pasa</a:t>
+              <a:t>• stdout = JSON para máquinas · stderr = veredicto humano · exit code = CI</a:t>
             </a:r>
           </a:p>
         </p:txBody>
@@ -6943,7 +7699,7 @@
                 </a:solidFill>
                 <a:latin typeface="Calibri"/>
               </a:rPr>
-              <a:t>Medir no es bloquear</a:t>
+              <a:t>Los números que ya conocen</a:t>
             </a:r>
           </a:p>
         </p:txBody>
@@ -6977,7 +7733,7 @@
                 </a:solidFill>
                 <a:latin typeface="Calibri"/>
               </a:rPr>
-              <a:t>Sesión 10 · Release Gate · Cierre · Slide 6</a:t>
+              <a:t>Sesión 10 · Release Gate · Cierre · Slide 5</a:t>
             </a:r>
           </a:p>
         </p:txBody>
@@ -7016,7 +7772,7 @@
                 </a:solidFill>
                 <a:latin typeface="Calibri"/>
               </a:rPr>
-              <a:t>• Ver sobrevivientes / WARN / diff ≠ rojo automático</a:t>
+              <a:t>• pass_rate ≥ 0.95 · p95 ≤ 500 ms</a:t>
             </a:r>
           </a:p>
           <a:p>
@@ -7032,7 +7788,7 @@
                 </a:solidFill>
                 <a:latin typeface="Calibri"/>
               </a:rPr>
-              <a:t>• El umbral decide (S6 K6 · S7 rules.tsv · S8 --enforce-gate · S9 gate/)</a:t>
+              <a:t>• ZAP fail_new ≤ 0 (WARN no bloquea)</a:t>
             </a:r>
           </a:p>
           <a:p>
@@ -7048,7 +7804,7 @@
                 </a:solidFill>
                 <a:latin typeface="Calibri"/>
               </a:rPr>
-              <a:t>• Hoy: un CLI que aplica todos los umbrales</a:t>
+              <a:t>• mutation ≥ 0.90 · a11y critical ≤ 0</a:t>
             </a:r>
           </a:p>
           <a:p>
@@ -7064,7 +7820,23 @@
                 </a:solidFill>
                 <a:latin typeface="Calibri"/>
               </a:rPr>
-              <a:t>• Cultura: acordar umbrales en equipo, no en silencio</a:t>
+              <a:t>• visual_diff ≤ 120 px (S9)</a:t>
+            </a:r>
+          </a:p>
+          <a:p>
+            <a:pPr>
+              <a:spcAft>
+                <a:spcPts val="1000"/>
+              </a:spcAft>
+            </a:pPr>
+            <a:r>
+              <a:rPr sz="1800" b="0">
+                <a:solidFill>
+                  <a:srgbClr val="2C3E50"/>
+                </a:solidFill>
+                <a:latin typeface="Calibri"/>
+              </a:rPr>
+              <a:t>• En el umbral exacto: pasa</a:t>
             </a:r>
           </a:p>
         </p:txBody>
@@ -7194,7 +7966,7 @@
                 </a:solidFill>
                 <a:latin typeface="Calibri"/>
               </a:rPr>
-              <a:t>Pausá 10</a:t>
+              <a:t>Medir no es bloquear</a:t>
             </a:r>
           </a:p>
         </p:txBody>
@@ -7228,7 +8000,7 @@
                 </a:solidFill>
                 <a:latin typeface="Calibri"/>
               </a:rPr>
-              <a:t>Sesión 10 · Release Gate · Cierre · Slide 7</a:t>
+              <a:t>Sesión 10 · Release Gate · Cierre · Slide 6</a:t>
             </a:r>
           </a:p>
         </p:txBody>
@@ -7267,7 +8039,55 @@
                 </a:solidFill>
                 <a:latin typeface="Calibri"/>
               </a:rPr>
-              <a:t>• Cuando volvamos: corremos el juez con tres JSON</a:t>
+              <a:t>• Ver sobrevivientes / WARN / diff ≠ rojo automático</a:t>
+            </a:r>
+          </a:p>
+          <a:p>
+            <a:pPr>
+              <a:spcAft>
+                <a:spcPts val="1000"/>
+              </a:spcAft>
+            </a:pPr>
+            <a:r>
+              <a:rPr sz="1800" b="0">
+                <a:solidFill>
+                  <a:srgbClr val="2C3E50"/>
+                </a:solidFill>
+                <a:latin typeface="Calibri"/>
+              </a:rPr>
+              <a:t>• El umbral decide (S6 K6 · S7 rules.tsv · S8 --enforce-gate · S9 gate/)</a:t>
+            </a:r>
+          </a:p>
+          <a:p>
+            <a:pPr>
+              <a:spcAft>
+                <a:spcPts val="1000"/>
+              </a:spcAft>
+            </a:pPr>
+            <a:r>
+              <a:rPr sz="1800" b="0">
+                <a:solidFill>
+                  <a:srgbClr val="2C3E50"/>
+                </a:solidFill>
+                <a:latin typeface="Calibri"/>
+              </a:rPr>
+              <a:t>• Hoy: un CLI que aplica todos los umbrales</a:t>
+            </a:r>
+          </a:p>
+          <a:p>
+            <a:pPr>
+              <a:spcAft>
+                <a:spcPts val="1000"/>
+              </a:spcAft>
+            </a:pPr>
+            <a:r>
+              <a:rPr sz="1800" b="0">
+                <a:solidFill>
+                  <a:srgbClr val="2C3E50"/>
+                </a:solidFill>
+                <a:latin typeface="Calibri"/>
+              </a:rPr>
+              <a:t>• Cultura: acordar umbrales en equipo, no en silencio</a:t>
             </a:r>
           </a:p>
         </p:txBody>
@@ -7397,7 +8217,7 @@
                 </a:solidFill>
                 <a:latin typeface="Calibri"/>
               </a:rPr>
-              <a:t>Lab del juez</a:t>
+              <a:t>Dónde vive el juez</a:t>
             </a:r>
           </a:p>
         </p:txBody>
@@ -7431,7 +8251,7 @@
                 </a:solidFill>
                 <a:latin typeface="Calibri"/>
               </a:rPr>
-              <a:t>Sesión 10 · Release Gate · Cierre · Slide 8</a:t>
+              <a:t>Sesión 10 · Release Gate · Cierre · Slide 6b</a:t>
             </a:r>
           </a:p>
         </p:txBody>
@@ -7470,7 +8290,7 @@
                 </a:solidFill>
                 <a:latin typeface="Calibri"/>
               </a:rPr>
-              <a:t>• Carpeta: proyecto-integrador/release-gate</a:t>
+              <a:t>• Último job del pipeline: needs: todos los anteriores</a:t>
             </a:r>
           </a:p>
           <a:p>
@@ -7486,7 +8306,7 @@
                 </a:solidFill>
                 <a:latin typeface="Calibri"/>
               </a:rPr>
-              <a:t>• Yo corro; vos podés seguir en silencio</a:t>
+              <a:t>• Las métricas viajan como artefactos entre jobs</a:t>
             </a:r>
           </a:p>
           <a:p>
@@ -7502,7 +8322,23 @@
                 </a:solidFill>
                 <a:latin typeface="Calibri"/>
               </a:rPr>
-              <a:t>• Objetivo: ver exit 0 y exit 1 y leer el JSON</a:t>
+              <a:t>• Required status check: sin verde no hay botón de merge</a:t>
+            </a:r>
+          </a:p>
+          <a:p>
+            <a:pPr>
+              <a:spcAft>
+                <a:spcPts val="1000"/>
+              </a:spcAft>
+            </a:pPr>
+            <a:r>
+              <a:rPr sz="1800" b="0">
+                <a:solidFill>
+                  <a:srgbClr val="2C3E50"/>
+                </a:solidFill>
+                <a:latin typeface="Calibri"/>
+              </a:rPr>
+              <a:t>• Saltarse el gate con permisos de admin = incidente, no atajo</a:t>
             </a:r>
           </a:p>
         </p:txBody>
@@ -7632,7 +8468,7 @@
                 </a:solidFill>
                 <a:latin typeface="Calibri"/>
               </a:rPr>
-              <a:t>Primero la suite del lab</a:t>
+              <a:t>Pausá 10</a:t>
             </a:r>
           </a:p>
         </p:txBody>
@@ -7666,7 +8502,7 @@
                 </a:solidFill>
                 <a:latin typeface="Calibri"/>
               </a:rPr>
-              <a:t>Sesión 10 · Release Gate · Cierre · Slide 9</a:t>
+              <a:t>Sesión 10 · Release Gate · Cierre · Slide 7</a:t>
             </a:r>
           </a:p>
         </p:txBody>
@@ -7705,55 +8541,7 @@
                 </a:solidFill>
                 <a:latin typeface="Calibri"/>
               </a:rPr>
-              <a:t>• uv sync --group dev</a:t>
-            </a:r>
-          </a:p>
-          <a:p>
-            <a:pPr>
-              <a:spcAft>
-                <a:spcPts val="1000"/>
-              </a:spcAft>
-            </a:pPr>
-            <a:r>
-              <a:rPr sz="1800" b="0">
-                <a:solidFill>
-                  <a:srgbClr val="2C3E50"/>
-                </a:solidFill>
-                <a:latin typeface="Calibri"/>
-              </a:rPr>
-              <a:t>• uv run pytest -v → 6 passed</a:t>
-            </a:r>
-          </a:p>
-          <a:p>
-            <a:pPr>
-              <a:spcAft>
-                <a:spcPts val="1000"/>
-              </a:spcAft>
-            </a:pPr>
-            <a:r>
-              <a:rPr sz="1800" b="0">
-                <a:solidFill>
-                  <a:srgbClr val="2C3E50"/>
-                </a:solidFill>
-                <a:latin typeface="Calibri"/>
-              </a:rPr>
-              <a:t>• El juez tiene tests propios (no es magia)</a:t>
-            </a:r>
-          </a:p>
-          <a:p>
-            <a:pPr>
-              <a:spcAft>
-                <a:spcPts val="1000"/>
-              </a:spcAft>
-            </a:pPr>
-            <a:r>
-              <a:rPr sz="1800" b="0">
-                <a:solidFill>
-                  <a:srgbClr val="2C3E50"/>
-                </a:solidFill>
-                <a:latin typeface="Calibri"/>
-              </a:rPr>
-              <a:t>• Task: task test:gate</a:t>
+              <a:t>• Cuando volvamos: corremos el juez con JSON sano y rojo</a:t>
             </a:r>
           </a:p>
         </p:txBody>

</xml_diff>